<commit_message>
Make project rebuildable and runnable from GitHub
</commit_message>
<xml_diff>
--- a/Documents/COMP3000 Poster Draft.pptx
+++ b/Documents/COMP3000 Poster Draft.pptx
@@ -241,7 +241,7 @@
           <a:p>
             <a:fld id="{00A2C23D-C45B-4A2C-BF87-5B14E866604E}" type="datetimeFigureOut">
               <a:rPr lang="en-US" smtClean="0"/>
-              <a:t>3/15/2026</a:t>
+              <a:t>5/3/2026</a:t>
             </a:fld>
             <a:endParaRPr lang="en-US"/>
           </a:p>
@@ -418,7 +418,7 @@
           <a:p>
             <a:fld id="{2E940DAB-E1CF-47C5-9FDC-D77F8612658A}" type="datetimeFigureOut">
               <a:rPr lang="en-US" smtClean="0"/>
-              <a:t>3/15/2026</a:t>
+              <a:t>5/3/2026</a:t>
             </a:fld>
             <a:endParaRPr lang="en-US"/>
           </a:p>
@@ -925,7 +925,7 @@
           <a:p>
             <a:fld id="{807E39B8-A7CB-4B82-AC0C-44B99F546761}" type="datetimeFigureOut">
               <a:rPr lang="en-US" dirty="0"/>
-              <a:t>3/15/2026</a:t>
+              <a:t>5/3/2026</a:t>
             </a:fld>
             <a:endParaRPr lang="en-US" dirty="0"/>
           </a:p>
@@ -1143,7 +1143,7 @@
           <a:p>
             <a:fld id="{01742F6F-0846-489A-A4BC-61B476BE2887}" type="datetimeFigureOut">
               <a:rPr lang="en-US" dirty="0"/>
-              <a:t>3/15/2026</a:t>
+              <a:t>5/3/2026</a:t>
             </a:fld>
             <a:endParaRPr lang="en-US" dirty="0"/>
           </a:p>
@@ -1355,7 +1355,7 @@
           <a:p>
             <a:fld id="{B229DF21-A340-467A-94AB-9502647BB771}" type="datetimeFigureOut">
               <a:rPr lang="en-US" dirty="0"/>
-              <a:t>3/15/2026</a:t>
+              <a:t>5/3/2026</a:t>
             </a:fld>
             <a:endParaRPr lang="en-US" dirty="0"/>
           </a:p>
@@ -2120,7 +2120,7 @@
           <a:p>
             <a:fld id="{FE7E3940-CA92-4FEE-A698-62CF7BC5AC36}" type="datetimeFigureOut">
               <a:rPr lang="en-US" dirty="0"/>
-              <a:t>3/15/2026</a:t>
+              <a:t>5/3/2026</a:t>
             </a:fld>
             <a:endParaRPr lang="en-US" dirty="0"/>
           </a:p>
@@ -2401,7 +2401,7 @@
           <a:p>
             <a:fld id="{E33CD641-6C35-45D1-9313-2719E9EA8AD8}" type="datetimeFigureOut">
               <a:rPr lang="en-US" dirty="0"/>
-              <a:t>3/15/2026</a:t>
+              <a:t>5/3/2026</a:t>
             </a:fld>
             <a:endParaRPr lang="en-US" dirty="0"/>
           </a:p>
@@ -2670,7 +2670,7 @@
           <a:p>
             <a:fld id="{35301268-3A74-4110-8F08-063DFB8BB885}" type="datetimeFigureOut">
               <a:rPr lang="en-US" dirty="0"/>
-              <a:t>3/15/2026</a:t>
+              <a:t>5/3/2026</a:t>
             </a:fld>
             <a:endParaRPr lang="en-US" dirty="0"/>
           </a:p>
@@ -3090,7 +3090,7 @@
           <a:p>
             <a:fld id="{BF91C1AF-C1FB-48A7-98B4-E595E63F6614}" type="datetimeFigureOut">
               <a:rPr lang="en-US" dirty="0"/>
-              <a:t>3/15/2026</a:t>
+              <a:t>5/3/2026</a:t>
             </a:fld>
             <a:endParaRPr lang="en-US" dirty="0"/>
           </a:p>
@@ -3235,7 +3235,7 @@
           <a:p>
             <a:fld id="{97144C44-5F8C-4BEA-BBCE-8694F126DC43}" type="datetimeFigureOut">
               <a:rPr lang="en-US" dirty="0"/>
-              <a:t>3/15/2026</a:t>
+              <a:t>5/3/2026</a:t>
             </a:fld>
             <a:endParaRPr lang="en-US" dirty="0"/>
           </a:p>
@@ -3352,7 +3352,7 @@
           <a:p>
             <a:fld id="{039E56F9-C8F2-4EF7-8042-704C94FF2795}" type="datetimeFigureOut">
               <a:rPr lang="en-US" dirty="0"/>
-              <a:t>3/15/2026</a:t>
+              <a:t>5/3/2026</a:t>
             </a:fld>
             <a:endParaRPr lang="en-US" dirty="0"/>
           </a:p>
@@ -3671,7 +3671,7 @@
           <a:p>
             <a:fld id="{4F6932DF-953D-44BD-83F8-5D8DA76EA12A}" type="datetimeFigureOut">
               <a:rPr lang="en-US" dirty="0"/>
-              <a:t>3/15/2026</a:t>
+              <a:t>5/3/2026</a:t>
             </a:fld>
             <a:endParaRPr lang="en-US" dirty="0"/>
           </a:p>
@@ -3965,7 +3965,7 @@
           <a:p>
             <a:fld id="{352F326D-65F4-4B2F-9A62-9E4BD9402C47}" type="datetimeFigureOut">
               <a:rPr lang="en-US" dirty="0"/>
-              <a:t>3/15/2026</a:t>
+              <a:t>5/3/2026</a:t>
             </a:fld>
             <a:endParaRPr lang="en-US" dirty="0"/>
           </a:p>
@@ -4265,7 +4265,7 @@
           <a:p>
             <a:fld id="{F9B0CB28-85DB-480B-8C99-FD493ACC7120}" type="datetimeFigureOut">
               <a:rPr lang="en-US" dirty="0"/>
-              <a:t>3/15/2026</a:t>
+              <a:t>5/3/2026</a:t>
             </a:fld>
             <a:endParaRPr lang="en-US" dirty="0"/>
           </a:p>
@@ -4742,7 +4742,7 @@
         <p:spPr>
           <a:xfrm>
             <a:off x="0" y="0"/>
-            <a:ext cx="43892438" cy="3662541"/>
+            <a:ext cx="43892438" cy="2185214"/>
           </a:xfrm>
           <a:prstGeom prst="rect">
             <a:avLst/>
@@ -4760,27 +4760,15 @@
           <a:p>
             <a:pPr algn="ctr"/>
             <a:r>
-              <a:rPr lang="en-US" sz="9600" b="1" u="sng" dirty="0"/>
-              <a:t>Unsupervised Fish Species Discovery </a:t>
+              <a:rPr lang="en-GB" sz="9600" b="1" dirty="0"/>
+              <a:t>Smart Aqua: Fish Detection, Crop Extraction, and Visual Clustering</a:t>
             </a:r>
           </a:p>
           <a:p>
             <a:pPr algn="ctr"/>
             <a:r>
-              <a:rPr lang="en-US" sz="9600" b="1" u="sng"/>
-              <a:t>Using Object Detection and Deep Visual Embeddings </a:t>
-            </a:r>
-            <a:endParaRPr lang="en-US" sz="9600" b="1" u="sng" dirty="0"/>
-          </a:p>
-          <a:p>
-            <a:pPr algn="ctr"/>
-            <a:r>
-              <a:rPr lang="en-US" sz="4000" b="1" u="sng"/>
-              <a:t>David</a:t>
-            </a:r>
-            <a:r>
               <a:rPr lang="en-US" sz="4000" b="1" u="sng" dirty="0"/>
-              <a:t> Wilson</a:t>
+              <a:t>David Wilson</a:t>
             </a:r>
           </a:p>
         </p:txBody>
@@ -4833,7 +4821,7 @@
               <a:rPr lang="en-US" sz="4800" b="1" u="sng" dirty="0"/>
               <a:t>Introduction</a:t>
             </a:r>
-            <a:endParaRPr lang="en-US"/>
+            <a:endParaRPr lang="en-US" dirty="0"/>
           </a:p>
           <a:p>
             <a:r>
@@ -4847,16 +4835,16 @@
           </a:p>
           <a:p>
             <a:r>
-              <a:rPr lang="en-US" sz="4000">
+              <a:rPr lang="en-US" sz="4000" dirty="0">
                 <a:ea typeface="+mn-lt"/>
                 <a:cs typeface="+mn-lt"/>
               </a:rPr>
               <a:t>annotation of underwater imagery, which is time-consuming and requires expert knowledge.</a:t>
             </a:r>
-            <a:endParaRPr lang="en-US"/>
-          </a:p>
-          <a:p>
-            <a:endParaRPr lang="en-US"/>
+            <a:endParaRPr lang="en-US" dirty="0"/>
+          </a:p>
+          <a:p>
+            <a:endParaRPr lang="en-US" dirty="0"/>
           </a:p>
           <a:p>
             <a:r>
@@ -4899,7 +4887,7 @@
             <a:endParaRPr lang="en-US" dirty="0"/>
           </a:p>
           <a:p>
-            <a:endParaRPr lang="en-US"/>
+            <a:endParaRPr lang="en-US" dirty="0"/>
           </a:p>
           <a:p>
             <a:r>
@@ -4917,7 +4905,7 @@
                 <a:ea typeface="+mn-lt"/>
                 <a:cs typeface="+mn-lt"/>
               </a:rPr>
-              <a:t>automatically group fish into species-like clusters without</a:t>
+              <a:t>automatically group fish into clusters without</a:t>
             </a:r>
             <a:endParaRPr lang="en-US" dirty="0"/>
           </a:p>
@@ -4988,26 +4976,12 @@
                 <a:ea typeface="+mn-lt"/>
                 <a:cs typeface="+mn-lt"/>
               </a:rPr>
-              <a:t>The goal of this project is to develop </a:t>
-            </a:r>
-            <a:r>
-              <a:rPr lang="en-US" sz="4000">
-                <a:ea typeface="+mn-lt"/>
-                <a:cs typeface="+mn-lt"/>
-              </a:rPr>
-              <a:t>an</a:t>
-            </a:r>
-            <a:r>
-              <a:rPr lang="en-US" sz="4000" dirty="0">
-                <a:ea typeface="+mn-lt"/>
-                <a:cs typeface="+mn-lt"/>
-              </a:rPr>
-              <a:t> AI capable of automatically grouping fish images into visually similar species clusters.</a:t>
-            </a:r>
-            <a:endParaRPr lang="en-US"/>
-          </a:p>
-          <a:p>
-            <a:endParaRPr lang="en-US"/>
+              <a:t>The goal of this project is to develop an AI capable of automatically grouping fish images into visually similar clusters.</a:t>
+            </a:r>
+            <a:endParaRPr lang="en-US" dirty="0"/>
+          </a:p>
+          <a:p>
+            <a:endParaRPr lang="en-US" dirty="0"/>
           </a:p>
           <a:p>
             <a:r>
@@ -5020,27 +4994,27 @@
             <a:endParaRPr lang="en-US" dirty="0"/>
           </a:p>
           <a:p>
-            <a:endParaRPr lang="en-US"/>
-          </a:p>
-          <a:p>
-            <a:r>
-              <a:rPr lang="en-US" sz="4000">
+            <a:endParaRPr lang="en-US" dirty="0"/>
+          </a:p>
+          <a:p>
+            <a:r>
+              <a:rPr lang="en-US" sz="4000" dirty="0">
                 <a:ea typeface="+mn-lt"/>
                 <a:cs typeface="+mn-lt"/>
               </a:rPr>
               <a:t>• Detect fish in underwater images using YOLOv8</a:t>
             </a:r>
-            <a:endParaRPr lang="en-US"/>
-          </a:p>
-          <a:p>
-            <a:r>
-              <a:rPr lang="en-US" sz="4000">
+            <a:endParaRPr lang="en-US" dirty="0"/>
+          </a:p>
+          <a:p>
+            <a:r>
+              <a:rPr lang="en-US" sz="4000" dirty="0">
                 <a:ea typeface="+mn-lt"/>
                 <a:cs typeface="+mn-lt"/>
               </a:rPr>
               <a:t>• Extract fish crops from detected bounding boxes</a:t>
             </a:r>
-            <a:endParaRPr lang="en-US"/>
+            <a:endParaRPr lang="en-US" dirty="0"/>
           </a:p>
           <a:p>
             <a:r>
@@ -5048,16 +5022,9 @@
                 <a:ea typeface="+mn-lt"/>
                 <a:cs typeface="+mn-lt"/>
               </a:rPr>
-              <a:t>• Generate deep visual embeddings from each </a:t>
-            </a:r>
-            <a:r>
-              <a:rPr lang="en-US" sz="4000">
-                <a:ea typeface="+mn-lt"/>
-                <a:cs typeface="+mn-lt"/>
-              </a:rPr>
-              <a:t>crop</a:t>
-            </a:r>
-            <a:endParaRPr lang="en-US"/>
+              <a:t>• Generate deep visual embeddings from each crop</a:t>
+            </a:r>
+            <a:endParaRPr lang="en-US" dirty="0"/>
           </a:p>
           <a:p>
             <a:r>
@@ -5065,16 +5032,9 @@
                 <a:ea typeface="+mn-lt"/>
                 <a:cs typeface="+mn-lt"/>
               </a:rPr>
-              <a:t>• Cluster fish using unsupervised </a:t>
-            </a:r>
-            <a:r>
-              <a:rPr lang="en-US" sz="4000">
-                <a:ea typeface="+mn-lt"/>
-                <a:cs typeface="+mn-lt"/>
-              </a:rPr>
-              <a:t>learning</a:t>
-            </a:r>
-            <a:endParaRPr lang="en-US" dirty="0" err="1"/>
+              <a:t>• Cluster fish using unsupervised learning</a:t>
+            </a:r>
+            <a:endParaRPr lang="en-US" dirty="0"/>
           </a:p>
           <a:p>
             <a:endParaRPr lang="en-US" sz="1750" dirty="0"/>
@@ -5114,7 +5074,7 @@
         <p:spPr>
           <a:xfrm>
             <a:off x="14747331" y="13828343"/>
-            <a:ext cx="14531545" cy="8217634"/>
+            <a:ext cx="14592502" cy="8833187"/>
           </a:xfrm>
           <a:prstGeom prst="rect">
             <a:avLst/>
@@ -5152,23 +5112,10 @@
           </a:p>
           <a:p>
             <a:r>
-              <a:rPr lang="en-US" sz="4000" dirty="0">
-                <a:ea typeface="+mn-lt"/>
-                <a:cs typeface="+mn-lt"/>
-              </a:rPr>
-              <a:t>The dataset consists of underwater imagery containing</a:t>
-            </a:r>
-            <a:endParaRPr lang="en-US" sz="4000" dirty="0"/>
-          </a:p>
-          <a:p>
-            <a:r>
-              <a:rPr lang="en-US" sz="4000" dirty="0">
-                <a:ea typeface="+mn-lt"/>
-                <a:cs typeface="+mn-lt"/>
-              </a:rPr>
-              <a:t>multiple fish species in natural marine environments.</a:t>
-            </a:r>
-            <a:endParaRPr lang="en-US" sz="4000" dirty="0"/>
+              <a:rPr lang="en-GB" sz="4000" dirty="0"/>
+              <a:t>The dataset consists of underwater/aquarium fish imagery containing multiple fish appearances, sizes, and backgrounds.</a:t>
+            </a:r>
+            <a:endParaRPr lang="en-GB" sz="4000" b="1" dirty="0"/>
           </a:p>
           <a:p>
             <a:endParaRPr lang="en-US" sz="4000" dirty="0"/>
@@ -5222,37 +5169,69 @@
                 <a:ea typeface="+mn-lt"/>
                 <a:cs typeface="+mn-lt"/>
               </a:rPr>
-              <a:t>From the dataset:</a:t>
+              <a:t>From the dataset: 80% training / 20% Validation</a:t>
             </a:r>
             <a:endParaRPr lang="en-US" sz="4000" dirty="0"/>
           </a:p>
           <a:p>
+            <a:pPr marL="571500" indent="-571500">
+              <a:buFont typeface="Arial" panose="020B0604020202020204" pitchFamily="34" charset="0"/>
+              <a:buChar char="•"/>
+            </a:pPr>
             <a:r>
               <a:rPr lang="en-US" sz="4000" dirty="0">
                 <a:ea typeface="+mn-lt"/>
                 <a:cs typeface="+mn-lt"/>
               </a:rPr>
-              <a:t>• 60 validation images per species </a:t>
-            </a:r>
-            <a:endParaRPr lang="en-US" sz="4000" dirty="0"/>
-          </a:p>
-          <a:p>
+              <a:t>3240 training images after augmentation</a:t>
+            </a:r>
+          </a:p>
+          <a:p>
+            <a:pPr marL="571500" indent="-571500">
+              <a:buFont typeface="Arial" panose="020B0604020202020204" pitchFamily="34" charset="0"/>
+              <a:buChar char="•"/>
+            </a:pPr>
             <a:r>
               <a:rPr lang="en-US" sz="4000" dirty="0">
                 <a:ea typeface="+mn-lt"/>
                 <a:cs typeface="+mn-lt"/>
               </a:rPr>
-              <a:t>• 15+ species used per test batch</a:t>
-            </a:r>
-            <a:endParaRPr lang="en-US" dirty="0"/>
-          </a:p>
-          <a:p>
+              <a:t>272 </a:t>
+            </a:r>
+            <a:r>
+              <a:rPr lang="en-US" sz="4000">
+                <a:ea typeface="+mn-lt"/>
+                <a:cs typeface="+mn-lt"/>
+              </a:rPr>
+              <a:t>validation images </a:t>
+            </a:r>
+            <a:endParaRPr lang="en-US" sz="4000" dirty="0"/>
+          </a:p>
+          <a:p>
+            <a:pPr marL="571500" indent="-571500">
+              <a:buFont typeface="Arial" panose="020B0604020202020204" pitchFamily="34" charset="0"/>
+              <a:buChar char="•"/>
+            </a:pPr>
             <a:r>
               <a:rPr lang="en-US" sz="4000" dirty="0">
                 <a:ea typeface="+mn-lt"/>
                 <a:cs typeface="+mn-lt"/>
               </a:rPr>
-              <a:t>• 767 annotated fish instances</a:t>
+              <a:t>Single “Fish” class used </a:t>
+            </a:r>
+            <a:endParaRPr lang="en-US" dirty="0"/>
+          </a:p>
+          <a:p>
+            <a:pPr marL="571500" indent="-571500">
+              <a:buFont typeface="Arial" panose="020B0604020202020204" pitchFamily="34" charset="0"/>
+              <a:buChar char="•"/>
+            </a:pPr>
+            <a:r>
+              <a:rPr lang="en-US" sz="4000" dirty="0">
+                <a:ea typeface="+mn-lt"/>
+                <a:cs typeface="+mn-lt"/>
+              </a:rPr>
+              <a:t>10945 annotated fish instances</a:t>
             </a:r>
             <a:endParaRPr lang="en-US" sz="4000" dirty="0"/>
           </a:p>
@@ -5545,8 +5524,8 @@
         </p:nvSpPr>
         <p:spPr>
           <a:xfrm>
-            <a:off x="14762384" y="22190514"/>
-            <a:ext cx="14614659" cy="10610277"/>
+            <a:off x="14747331" y="22953761"/>
+            <a:ext cx="14614659" cy="9379171"/>
           </a:xfrm>
           <a:prstGeom prst="rect">
             <a:avLst/>
@@ -5671,7 +5650,7 @@
           <a:p>
             <a:r>
               <a:rPr lang="en-US" sz="4000" dirty="0"/>
-              <a:t>improve detection </a:t>
+              <a:t>improve detection</a:t>
             </a:r>
             <a:endParaRPr lang="en-US" sz="1750" dirty="0"/>
           </a:p>
@@ -5680,13 +5659,6 @@
               <a:rPr lang="en-US" sz="4000" dirty="0"/>
               <a:t>Reliability</a:t>
             </a:r>
-            <a:endParaRPr lang="en-US" sz="1750" dirty="0"/>
-          </a:p>
-          <a:p>
-            <a:endParaRPr lang="en-US" sz="4000" dirty="0"/>
-          </a:p>
-          <a:p>
-            <a:endParaRPr lang="en-US" sz="4000" dirty="0"/>
           </a:p>
         </p:txBody>
       </p:sp>
@@ -5820,7 +5792,7 @@
                 <a:ea typeface="+mn-lt"/>
                 <a:cs typeface="+mn-lt"/>
               </a:rPr>
-              <a:t>species precisely, the approach shows </a:t>
+              <a:t>clusters precisely, the approach shows </a:t>
             </a:r>
           </a:p>
           <a:p>
@@ -6081,16 +6053,9 @@
                 <a:ea typeface="+mn-lt"/>
                 <a:cs typeface="+mn-lt"/>
               </a:rPr>
-              <a:t>The YOLOv8 detection model achieved </a:t>
-            </a:r>
-            <a:r>
-              <a:rPr lang="en-US" sz="3800">
-                <a:ea typeface="+mn-lt"/>
-                <a:cs typeface="+mn-lt"/>
-              </a:rPr>
-              <a:t>impressive performance</a:t>
-            </a:r>
-            <a:endParaRPr lang="en-US" sz="3800"/>
+              <a:t>The YOLOv8 detection model achieved impressive performance</a:t>
+            </a:r>
+            <a:endParaRPr lang="en-US" sz="3800" dirty="0"/>
           </a:p>
           <a:p>
             <a:r>
@@ -6111,7 +6076,7 @@
                 <a:ea typeface="+mn-lt"/>
                 <a:cs typeface="+mn-lt"/>
               </a:rPr>
-              <a:t>Detection metrics:</a:t>
+              <a:t>Example Detection metrics:</a:t>
             </a:r>
             <a:endParaRPr lang="en-US" sz="3800" dirty="0"/>
           </a:p>
@@ -6124,7 +6089,7 @@
                 <a:ea typeface="+mn-lt"/>
                 <a:cs typeface="+mn-lt"/>
               </a:rPr>
-              <a:t>Precision: 0.913</a:t>
+              <a:t>Precision: 0.898</a:t>
             </a:r>
             <a:endParaRPr lang="en-US" sz="3800" dirty="0"/>
           </a:p>
@@ -6134,7 +6099,7 @@
                 <a:ea typeface="+mn-lt"/>
                 <a:cs typeface="+mn-lt"/>
               </a:rPr>
-              <a:t>Recall: 0.776</a:t>
+              <a:t>Recall: 0.8</a:t>
             </a:r>
             <a:endParaRPr lang="en-US" sz="3800" dirty="0"/>
           </a:p>
@@ -6144,7 +6109,7 @@
                 <a:ea typeface="+mn-lt"/>
                 <a:cs typeface="+mn-lt"/>
               </a:rPr>
-              <a:t>mAP@50: 0.871</a:t>
+              <a:t>mAP50: 0.871</a:t>
             </a:r>
             <a:endParaRPr lang="en-US" sz="3800" dirty="0"/>
           </a:p>
@@ -6154,7 +6119,7 @@
                 <a:ea typeface="+mn-lt"/>
                 <a:cs typeface="+mn-lt"/>
               </a:rPr>
-              <a:t>mAP@50-95: 0.603</a:t>
+              <a:t>mAP50-95: 0.651</a:t>
             </a:r>
             <a:endParaRPr lang="en-US" sz="3800" dirty="0"/>
           </a:p>
@@ -6195,10 +6160,10 @@
       </p:sp>
       <p:pic>
         <p:nvPicPr>
-          <p:cNvPr id="44" name="Picture 43" descr="A diagram of a fish processing process&#10;&#10;AI-generated content may be incorrect.">
-            <a:extLst>
-              <a:ext uri="{FF2B5EF4-FFF2-40B4-BE49-F238E27FC236}">
-                <a16:creationId xmlns:a16="http://schemas.microsoft.com/office/drawing/2014/main" id="{54D54E6E-481E-3E1A-9D40-0D0C8E5A696A}"/>
+          <p:cNvPr id="49" name="Picture 48" descr="A screenshot of a computer&#10;&#10;AI-generated content may be incorrect.">
+            <a:extLst>
+              <a:ext uri="{FF2B5EF4-FFF2-40B4-BE49-F238E27FC236}">
+                <a16:creationId xmlns:a16="http://schemas.microsoft.com/office/drawing/2014/main" id="{C626ECEE-BB4F-1F00-4AF1-EF1539BD951C}"/>
               </a:ext>
             </a:extLst>
           </p:cNvPr>
@@ -6209,36 +6174,6 @@
         </p:nvPicPr>
         <p:blipFill>
           <a:blip r:embed="rId4"/>
-          <a:stretch>
-            <a:fillRect/>
-          </a:stretch>
-        </p:blipFill>
-        <p:spPr>
-          <a:xfrm>
-            <a:off x="5773252" y="10754910"/>
-            <a:ext cx="8370487" cy="21854301"/>
-          </a:xfrm>
-          <a:prstGeom prst="rect">
-            <a:avLst/>
-          </a:prstGeom>
-        </p:spPr>
-      </p:pic>
-      <p:pic>
-        <p:nvPicPr>
-          <p:cNvPr id="49" name="Picture 48" descr="A screenshot of a computer&#10;&#10;AI-generated content may be incorrect.">
-            <a:extLst>
-              <a:ext uri="{FF2B5EF4-FFF2-40B4-BE49-F238E27FC236}">
-                <a16:creationId xmlns:a16="http://schemas.microsoft.com/office/drawing/2014/main" id="{C626ECEE-BB4F-1F00-4AF1-EF1539BD951C}"/>
-              </a:ext>
-            </a:extLst>
-          </p:cNvPr>
-          <p:cNvPicPr>
-            <a:picLocks noChangeAspect="1"/>
-          </p:cNvPicPr>
-          <p:nvPr/>
-        </p:nvPicPr>
-        <p:blipFill>
-          <a:blip r:embed="rId5"/>
           <a:stretch>
             <a:fillRect/>
           </a:stretch>
@@ -6268,7 +6203,7 @@
           <p:nvPr/>
         </p:nvPicPr>
         <p:blipFill>
-          <a:blip r:embed="rId6"/>
+          <a:blip r:embed="rId5"/>
           <a:stretch>
             <a:fillRect/>
           </a:stretch>
@@ -6298,15 +6233,15 @@
           <p:nvPr/>
         </p:nvPicPr>
         <p:blipFill>
-          <a:blip r:embed="rId7"/>
+          <a:blip r:embed="rId6"/>
           <a:stretch>
             <a:fillRect/>
           </a:stretch>
         </p:blipFill>
         <p:spPr>
           <a:xfrm>
-            <a:off x="23626010" y="19164030"/>
-            <a:ext cx="4886645" cy="2526147"/>
+            <a:off x="24467162" y="20307327"/>
+            <a:ext cx="4331743" cy="2239291"/>
           </a:xfrm>
           <a:prstGeom prst="rect">
             <a:avLst/>
@@ -6328,7 +6263,7 @@
           <p:nvPr/>
         </p:nvPicPr>
         <p:blipFill>
-          <a:blip r:embed="rId8"/>
+          <a:blip r:embed="rId7"/>
           <a:stretch>
             <a:fillRect/>
           </a:stretch>
@@ -6358,7 +6293,7 @@
           <p:nvPr/>
         </p:nvPicPr>
         <p:blipFill>
-          <a:blip r:embed="rId9"/>
+          <a:blip r:embed="rId8"/>
           <a:stretch>
             <a:fillRect/>
           </a:stretch>
@@ -6388,15 +6323,15 @@
           <p:nvPr/>
         </p:nvPicPr>
         <p:blipFill>
-          <a:blip r:embed="rId10"/>
+          <a:blip r:embed="rId9"/>
           <a:stretch>
             <a:fillRect/>
           </a:stretch>
         </p:blipFill>
         <p:spPr>
           <a:xfrm>
-            <a:off x="20490821" y="27782964"/>
-            <a:ext cx="8021834" cy="4523423"/>
+            <a:off x="21116500" y="28277368"/>
+            <a:ext cx="6701324" cy="3778802"/>
           </a:xfrm>
           <a:prstGeom prst="rect">
             <a:avLst/>
@@ -6409,6 +6344,81 @@
             <a:extLst>
               <a:ext uri="{FF2B5EF4-FFF2-40B4-BE49-F238E27FC236}">
                 <a16:creationId xmlns:a16="http://schemas.microsoft.com/office/drawing/2014/main" id="{A4093822-C187-3ADA-6CB3-A32916812C1D}"/>
+              </a:ext>
+            </a:extLst>
+          </p:cNvPr>
+          <p:cNvPicPr>
+            <a:picLocks noChangeAspect="1"/>
+          </p:cNvPicPr>
+          <p:nvPr/>
+        </p:nvPicPr>
+        <p:blipFill>
+          <a:blip r:embed="rId10"/>
+          <a:stretch>
+            <a:fillRect/>
+          </a:stretch>
+        </p:blipFill>
+        <p:spPr>
+          <a:xfrm>
+            <a:off x="39597280" y="23874361"/>
+            <a:ext cx="3991649" cy="3768986"/>
+          </a:xfrm>
+          <a:prstGeom prst="rect">
+            <a:avLst/>
+          </a:prstGeom>
+        </p:spPr>
+      </p:pic>
+      <p:sp>
+        <p:nvSpPr>
+          <p:cNvPr id="5" name="AutoShape 2">
+            <a:extLst>
+              <a:ext uri="{FF2B5EF4-FFF2-40B4-BE49-F238E27FC236}">
+                <a16:creationId xmlns:a16="http://schemas.microsoft.com/office/drawing/2014/main" id="{188687BB-2485-3966-4DAF-99926097DCB4}"/>
+              </a:ext>
+            </a:extLst>
+          </p:cNvPr>
+          <p:cNvSpPr>
+            <a:spLocks noChangeAspect="1" noChangeArrowheads="1"/>
+          </p:cNvSpPr>
+          <p:nvPr/>
+        </p:nvSpPr>
+        <p:spPr bwMode="auto">
+          <a:xfrm>
+            <a:off x="21793200" y="16306800"/>
+            <a:ext cx="304800" cy="304800"/>
+          </a:xfrm>
+          <a:prstGeom prst="rect">
+            <a:avLst/>
+          </a:prstGeom>
+          <a:noFill/>
+          <a:extLst>
+            <a:ext uri="{909E8E84-426E-40DD-AFC4-6F175D3DCCD1}">
+              <a14:hiddenFill xmlns:a14="http://schemas.microsoft.com/office/drawing/2010/main">
+                <a:solidFill>
+                  <a:srgbClr val="FFFFFF"/>
+                </a:solidFill>
+              </a14:hiddenFill>
+            </a:ext>
+          </a:extLst>
+        </p:spPr>
+        <p:txBody>
+          <a:bodyPr vert="horz" wrap="square" lIns="91440" tIns="45720" rIns="91440" bIns="45720" numCol="1" anchor="t" anchorCtr="0" compatLnSpc="1">
+            <a:prstTxWarp prst="textNoShape">
+              <a:avLst/>
+            </a:prstTxWarp>
+          </a:bodyPr>
+          <a:lstStyle/>
+          <a:p>
+            <a:endParaRPr lang="en-GB"/>
+          </a:p>
+        </p:txBody>
+      </p:sp>
+      <p:pic>
+        <p:nvPicPr>
+          <p:cNvPr id="8" name="Picture 7">
+            <a:extLst>
+              <a:ext uri="{FF2B5EF4-FFF2-40B4-BE49-F238E27FC236}">
+                <a16:creationId xmlns:a16="http://schemas.microsoft.com/office/drawing/2014/main" id="{870122F2-7F8D-4A33-9B73-F4C00E0DA4A5}"/>
               </a:ext>
             </a:extLst>
           </p:cNvPr>
@@ -6425,8 +6435,8 @@
         </p:blipFill>
         <p:spPr>
           <a:xfrm>
-            <a:off x="39597280" y="23874361"/>
-            <a:ext cx="3991649" cy="3768986"/>
+            <a:off x="5684529" y="10617972"/>
+            <a:ext cx="8544039" cy="22255316"/>
           </a:xfrm>
           <a:prstGeom prst="rect">
             <a:avLst/>
@@ -7258,12 +7268,23 @@
 </file>
 
 <file path=customXml/item1.xml><?xml version="1.0" encoding="utf-8"?>
-<?mso-contentType ?>
-<FormTemplates xmlns="http://schemas.microsoft.com/sharepoint/v3/contenttype/forms">
-  <Display>DocumentLibraryForm</Display>
-  <Edit>DocumentLibraryForm</Edit>
-  <New>DocumentLibraryForm</New>
-</FormTemplates>
+<p:properties xmlns:p="http://schemas.microsoft.com/office/2006/metadata/properties" xmlns:xsi="http://www.w3.org/2001/XMLSchema-instance" xmlns:pc="http://schemas.microsoft.com/office/infopath/2007/PartnerControls">
+  <documentManagement>
+    <_ip_UnifiedCompliancePolicyUIAction xmlns="http://schemas.microsoft.com/sharepoint/v3" xsi:nil="true"/>
+    <Image xmlns="71af3243-3dd4-4a8d-8c0d-dd76da1f02a5">
+      <Url xsi:nil="true"/>
+      <Description xsi:nil="true"/>
+    </Image>
+    <Status xmlns="71af3243-3dd4-4a8d-8c0d-dd76da1f02a5">Not started</Status>
+    <Background xmlns="71af3243-3dd4-4a8d-8c0d-dd76da1f02a5">false</Background>
+    <_ip_UnifiedCompliancePolicyProperties xmlns="http://schemas.microsoft.com/sharepoint/v3" xsi:nil="true"/>
+    <ImageTagsTaxHTField xmlns="71af3243-3dd4-4a8d-8c0d-dd76da1f02a5">
+      <Terms xmlns="http://schemas.microsoft.com/office/infopath/2007/PartnerControls"/>
+    </ImageTagsTaxHTField>
+    <TaxCatchAll xmlns="230e9df3-be65-4c73-a93b-d1236ebd677e" xsi:nil="true"/>
+    <MediaServiceKeyPoints xmlns="71af3243-3dd4-4a8d-8c0d-dd76da1f02a5" xsi:nil="true"/>
+  </documentManagement>
+</p:properties>
 </file>
 
 <file path=customXml/item2.xml><?xml version="1.0" encoding="utf-8"?>
@@ -7579,29 +7600,29 @@
 </file>
 
 <file path=customXml/item3.xml><?xml version="1.0" encoding="utf-8"?>
-<p:properties xmlns:p="http://schemas.microsoft.com/office/2006/metadata/properties" xmlns:xsi="http://www.w3.org/2001/XMLSchema-instance" xmlns:pc="http://schemas.microsoft.com/office/infopath/2007/PartnerControls">
-  <documentManagement>
-    <_ip_UnifiedCompliancePolicyUIAction xmlns="http://schemas.microsoft.com/sharepoint/v3" xsi:nil="true"/>
-    <Image xmlns="71af3243-3dd4-4a8d-8c0d-dd76da1f02a5">
-      <Url xsi:nil="true"/>
-      <Description xsi:nil="true"/>
-    </Image>
-    <Status xmlns="71af3243-3dd4-4a8d-8c0d-dd76da1f02a5">Not started</Status>
-    <Background xmlns="71af3243-3dd4-4a8d-8c0d-dd76da1f02a5">false</Background>
-    <_ip_UnifiedCompliancePolicyProperties xmlns="http://schemas.microsoft.com/sharepoint/v3" xsi:nil="true"/>
-    <ImageTagsTaxHTField xmlns="71af3243-3dd4-4a8d-8c0d-dd76da1f02a5">
-      <Terms xmlns="http://schemas.microsoft.com/office/infopath/2007/PartnerControls"/>
-    </ImageTagsTaxHTField>
-    <TaxCatchAll xmlns="230e9df3-be65-4c73-a93b-d1236ebd677e" xsi:nil="true"/>
-    <MediaServiceKeyPoints xmlns="71af3243-3dd4-4a8d-8c0d-dd76da1f02a5" xsi:nil="true"/>
-  </documentManagement>
-</p:properties>
+<?mso-contentType ?>
+<FormTemplates xmlns="http://schemas.microsoft.com/sharepoint/v3/contenttype/forms">
+  <Display>DocumentLibraryForm</Display>
+  <Edit>DocumentLibraryForm</Edit>
+  <New>DocumentLibraryForm</New>
+</FormTemplates>
 </file>
 
 <file path=customXml/itemProps1.xml><?xml version="1.0" encoding="utf-8"?>
-<ds:datastoreItem xmlns:ds="http://schemas.openxmlformats.org/officeDocument/2006/customXml" ds:itemID="{79B9E6A9-7819-4063-83F2-25CE73BED697}">
+<ds:datastoreItem xmlns:ds="http://schemas.openxmlformats.org/officeDocument/2006/customXml" ds:itemID="{089965BD-26A5-4115-85B7-F70113F2497C}">
   <ds:schemaRefs>
-    <ds:schemaRef ds:uri="http://schemas.microsoft.com/sharepoint/v3/contenttype/forms"/>
+    <ds:schemaRef ds:uri="http://www.w3.org/XML/1998/namespace"/>
+    <ds:schemaRef ds:uri="http://schemas.microsoft.com/office/2006/documentManagement/types"/>
+    <ds:schemaRef ds:uri="http://schemas.openxmlformats.org/package/2006/metadata/core-properties"/>
+    <ds:schemaRef ds:uri="71af3243-3dd4-4a8d-8c0d-dd76da1f02a5"/>
+    <ds:schemaRef ds:uri="230e9df3-be65-4c73-a93b-d1236ebd677e"/>
+    <ds:schemaRef ds:uri="http://purl.org/dc/elements/1.1/"/>
+    <ds:schemaRef ds:uri="http://purl.org/dc/dcmitype/"/>
+    <ds:schemaRef ds:uri="http://schemas.microsoft.com/sharepoint/v3"/>
+    <ds:schemaRef ds:uri="http://schemas.microsoft.com/office/2006/metadata/properties"/>
+    <ds:schemaRef ds:uri="http://schemas.microsoft.com/office/infopath/2007/PartnerControls"/>
+    <ds:schemaRef ds:uri="16c05727-aa75-4e4a-9b5f-8a80a1165891"/>
+    <ds:schemaRef ds:uri="http://purl.org/dc/terms/"/>
   </ds:schemaRefs>
 </ds:datastoreItem>
 </file>
@@ -7628,20 +7649,9 @@
 </file>
 
 <file path=customXml/itemProps3.xml><?xml version="1.0" encoding="utf-8"?>
-<ds:datastoreItem xmlns:ds="http://schemas.openxmlformats.org/officeDocument/2006/customXml" ds:itemID="{089965BD-26A5-4115-85B7-F70113F2497C}">
+<ds:datastoreItem xmlns:ds="http://schemas.openxmlformats.org/officeDocument/2006/customXml" ds:itemID="{79B9E6A9-7819-4063-83F2-25CE73BED697}">
   <ds:schemaRefs>
-    <ds:schemaRef ds:uri="http://www.w3.org/XML/1998/namespace"/>
-    <ds:schemaRef ds:uri="http://schemas.microsoft.com/office/2006/documentManagement/types"/>
-    <ds:schemaRef ds:uri="http://schemas.openxmlformats.org/package/2006/metadata/core-properties"/>
-    <ds:schemaRef ds:uri="71af3243-3dd4-4a8d-8c0d-dd76da1f02a5"/>
-    <ds:schemaRef ds:uri="230e9df3-be65-4c73-a93b-d1236ebd677e"/>
-    <ds:schemaRef ds:uri="http://purl.org/dc/elements/1.1/"/>
-    <ds:schemaRef ds:uri="http://purl.org/dc/dcmitype/"/>
-    <ds:schemaRef ds:uri="http://schemas.microsoft.com/sharepoint/v3"/>
-    <ds:schemaRef ds:uri="http://schemas.microsoft.com/office/2006/metadata/properties"/>
-    <ds:schemaRef ds:uri="http://schemas.microsoft.com/office/infopath/2007/PartnerControls"/>
-    <ds:schemaRef ds:uri="16c05727-aa75-4e4a-9b5f-8a80a1165891"/>
-    <ds:schemaRef ds:uri="http://purl.org/dc/terms/"/>
+    <ds:schemaRef ds:uri="http://schemas.microsoft.com/sharepoint/v3/contenttype/forms"/>
   </ds:schemaRefs>
 </ds:datastoreItem>
 </file>

</xml_diff>